<commit_message>
Record JMIR withdrawal confirmation; archive SS-293 review form
- ms#111728 CLOSED: JMIR 'Decision E: Withdrawn by Author' received
  14 Sep 2026 (Dola Majekodunmi, Managing Editor); transcribed into
  the withdrawal record; tracker A11b added, A11/A11a closed. Paper-3
  JMIR venue option unblocked on the journal side.
- SS-293 review form archived (Publish in minor, required changes;
  three formatting-level changes, none on consent); SS-293_Record.md
  created; consent-statement check recorded as author-reported done,
  camera-ready PDF still wanted for the evidence pack.
- Rev F slide-7 speaker notes updated with both closures.

Co-Authored-By: Claude Fable 5 <noreply@anthropic.com>
Claude-Session: https://claude.ai/code/session_01KoT3i8geZspYBMMKVYJUTG
</commit_message>
<xml_diff>
--- a/docs/presentations/EngD_Update_8_Final_Review_September2026_revF.pptx
+++ b/docs/presentations/EngD_Update_8_Final_Review_September2026_revF.pptx
@@ -1506,7 +1506,7 @@
           </a:p>
           <a:p>
             <a:r>
-              <a:t>Tam &amp; Cheung. Accepted and presented March 2026; IEEE Xplore indexing pending. Camera-ready consent-statement check open.</a:t>
+              <a:t>Tam &amp; Cheung. Accepted and presented March 2026; IEEE Xplore indexing pending. Camera-ready consent-statement check done (14 Sep); review form archived — minor formatting changes only, none on consent.</a:t>
             </a:r>
           </a:p>
           <a:p/>
@@ -1538,7 +1538,7 @@
           </a:p>
           <a:p>
             <a:r>
-              <a:t>Two complete submission packages (JMIR Serious Games; IEEE Access alternative). Submission awaits the supervisor's venue approval; co-author ORCID needed for the forms.</a:t>
+              <a:t>Two complete submission packages (JMIR Serious Games; IEEE Access alternative). Submission awaits the supervisor's venue approval; co-author ORCID needed for the forms. JMIR path cleared: ms#111728 withdrawal confirmed by JMIR 14 Sep (Decision E: Withdrawn by Author).</a:t>
             </a:r>
           </a:p>
           <a:p/>

</xml_diff>